<commit_message>
Update slide deck for finalist presentation
</commit_message>
<xml_diff>
--- a/reports/slides/output/CityPulse_finalist_deck.pptx
+++ b/reports/slides/output/CityPulse_finalist_deck.pptx
@@ -2074,7 +2074,7 @@
           </a:prstGeom>
           <a:extLst>
             <a:ext uri="{C572A759-6A51-4108-AA02-DFA0A04FC94B}">
-              <ma14:wrappingTextBoxFlag xmlns:ma14="http://schemas.microsoft.com/office/mac/drawingml/2011/main" xmlns="" val="0"/>
+              <ma14:wrappingTextBoxFlag xmlns="" xmlns:ma14="http://schemas.microsoft.com/office/mac/drawingml/2011/main" val="0"/>
             </a:ext>
           </a:extLst>
         </p:spPr>
@@ -2333,7 +2333,7 @@
           </a:prstGeom>
           <a:extLst>
             <a:ext uri="{C572A759-6A51-4108-AA02-DFA0A04FC94B}">
-              <ma14:wrappingTextBoxFlag xmlns:ma14="http://schemas.microsoft.com/office/mac/drawingml/2011/main" xmlns="" val="0"/>
+              <ma14:wrappingTextBoxFlag xmlns="" xmlns:ma14="http://schemas.microsoft.com/office/mac/drawingml/2011/main" val="0"/>
             </a:ext>
           </a:extLst>
         </p:spPr>
@@ -2948,9 +2948,7 @@
           <a:bodyPr wrap="square" lIns="0" tIns="0" rIns="0" bIns="0" rtlCol="0" anchor="t"/>
           <a:lstStyle/>
           <a:p>
-            <a:pPr marL="0" indent="0" algn="ctr">
-              <a:buNone/>
-            </a:pPr>
+            <a:pPr algn="ctr"/>
             <a:r>
               <a:rPr lang="en-US" sz="1400" b="1" dirty="0">
                 <a:solidFill>
@@ -2970,7 +2968,7 @@
                 <a:cs typeface="Times New Roman" panose="02020603050405020304" pitchFamily="18" charset="0"/>
                 <a:hlinkClick r:id="rId4"/>
               </a:rPr>
-              <a:t>citypulse-mumbai.streamlit.app</a:t>
+              <a:t>https://citypulseaweb.streamlit.app/</a:t>
             </a:r>
             <a:endParaRPr lang="en-US" sz="1400" b="1" dirty="0">
               <a:latin typeface="Times New Roman" panose="02020603050405020304" pitchFamily="18" charset="0"/>
@@ -4029,7 +4027,7 @@
           </a:prstGeom>
           <a:extLst>
             <a:ext uri="{C572A759-6A51-4108-AA02-DFA0A04FC94B}">
-              <ma14:wrappingTextBoxFlag xmlns:ma14="http://schemas.microsoft.com/office/mac/drawingml/2011/main" xmlns="" val="0"/>
+              <ma14:wrappingTextBoxFlag xmlns="" xmlns:ma14="http://schemas.microsoft.com/office/mac/drawingml/2011/main" val="0"/>
             </a:ext>
           </a:extLst>
         </p:spPr>
@@ -4476,9 +4474,6 @@
           <a:bodyPr wrap="square" lIns="0" tIns="0" rIns="0" bIns="0" rtlCol="0" anchor="t"/>
           <a:lstStyle/>
           <a:p>
-            <a:pPr marL="0" indent="0">
-              <a:buNone/>
-            </a:pPr>
             <a:r>
               <a:rPr lang="en-US" sz="1600" b="1" dirty="0">
                 <a:solidFill>
@@ -4498,7 +4493,7 @@
                 <a:cs typeface="Times New Roman" panose="02020603050405020304" pitchFamily="18" charset="0"/>
                 <a:hlinkClick r:id="rId3"/>
               </a:rPr>
-              <a:t>citypulse-mumbai.streamlit.app</a:t>
+              <a:t>https://citypulseaweb.streamlit.app/</a:t>
             </a:r>
             <a:endParaRPr lang="en-US" sz="1600" b="1" dirty="0">
               <a:latin typeface="Times New Roman" panose="02020603050405020304" pitchFamily="18" charset="0"/>
@@ -5134,7 +5129,7 @@
           </a:prstGeom>
           <a:extLst>
             <a:ext uri="{C572A759-6A51-4108-AA02-DFA0A04FC94B}">
-              <ma14:wrappingTextBoxFlag xmlns:ma14="http://schemas.microsoft.com/office/mac/drawingml/2011/main" xmlns="" val="0"/>
+              <ma14:wrappingTextBoxFlag xmlns="" xmlns:ma14="http://schemas.microsoft.com/office/mac/drawingml/2011/main" val="0"/>
             </a:ext>
           </a:extLst>
         </p:spPr>
@@ -5647,7 +5642,7 @@
           </a:prstGeom>
           <a:extLst>
             <a:ext uri="{C572A759-6A51-4108-AA02-DFA0A04FC94B}">
-              <ma14:wrappingTextBoxFlag xmlns:ma14="http://schemas.microsoft.com/office/mac/drawingml/2011/main" xmlns="" val="0"/>
+              <ma14:wrappingTextBoxFlag xmlns="" xmlns:ma14="http://schemas.microsoft.com/office/mac/drawingml/2011/main" val="0"/>
             </a:ext>
           </a:extLst>
         </p:spPr>
@@ -6421,7 +6416,7 @@
           </a:prstGeom>
           <a:extLst>
             <a:ext uri="{C572A759-6A51-4108-AA02-DFA0A04FC94B}">
-              <ma14:wrappingTextBoxFlag xmlns:ma14="http://schemas.microsoft.com/office/mac/drawingml/2011/main" xmlns="" val="0"/>
+              <ma14:wrappingTextBoxFlag xmlns="" xmlns:ma14="http://schemas.microsoft.com/office/mac/drawingml/2011/main" val="0"/>
             </a:ext>
           </a:extLst>
         </p:spPr>
@@ -6851,7 +6846,7 @@
           </a:prstGeom>
           <a:extLst>
             <a:ext uri="{C572A759-6A51-4108-AA02-DFA0A04FC94B}">
-              <ma14:wrappingTextBoxFlag xmlns:ma14="http://schemas.microsoft.com/office/mac/drawingml/2011/main" xmlns="" val="0"/>
+              <ma14:wrappingTextBoxFlag xmlns="" xmlns:ma14="http://schemas.microsoft.com/office/mac/drawingml/2011/main" val="0"/>
             </a:ext>
           </a:extLst>
         </p:spPr>
@@ -7076,7 +7071,7 @@
           </a:prstGeom>
           <a:extLst>
             <a:ext uri="{C572A759-6A51-4108-AA02-DFA0A04FC94B}">
-              <ma14:wrappingTextBoxFlag xmlns:ma14="http://schemas.microsoft.com/office/mac/drawingml/2011/main" xmlns="" val="0"/>
+              <ma14:wrappingTextBoxFlag xmlns="" xmlns:ma14="http://schemas.microsoft.com/office/mac/drawingml/2011/main" val="0"/>
             </a:ext>
           </a:extLst>
         </p:spPr>
@@ -7653,7 +7648,7 @@
           </a:prstGeom>
           <a:extLst>
             <a:ext uri="{C572A759-6A51-4108-AA02-DFA0A04FC94B}">
-              <ma14:wrappingTextBoxFlag xmlns:ma14="http://schemas.microsoft.com/office/mac/drawingml/2011/main" xmlns="" val="0"/>
+              <ma14:wrappingTextBoxFlag xmlns="" xmlns:ma14="http://schemas.microsoft.com/office/mac/drawingml/2011/main" val="0"/>
             </a:ext>
           </a:extLst>
         </p:spPr>
@@ -7925,7 +7920,7 @@
           </a:prstGeom>
           <a:extLst>
             <a:ext uri="{C572A759-6A51-4108-AA02-DFA0A04FC94B}">
-              <ma14:wrappingTextBoxFlag xmlns:ma14="http://schemas.microsoft.com/office/mac/drawingml/2011/main" xmlns="" val="0"/>
+              <ma14:wrappingTextBoxFlag xmlns="" xmlns:ma14="http://schemas.microsoft.com/office/mac/drawingml/2011/main" val="0"/>
             </a:ext>
           </a:extLst>
         </p:spPr>
@@ -9451,7 +9446,7 @@
           </a:prstGeom>
           <a:extLst>
             <a:ext uri="{C572A759-6A51-4108-AA02-DFA0A04FC94B}">
-              <ma14:wrappingTextBoxFlag xmlns:ma14="http://schemas.microsoft.com/office/mac/drawingml/2011/main" xmlns="" val="0"/>
+              <ma14:wrappingTextBoxFlag xmlns="" xmlns:ma14="http://schemas.microsoft.com/office/mac/drawingml/2011/main" val="0"/>
             </a:ext>
           </a:extLst>
         </p:spPr>

</xml_diff>